<commit_message>
Update gitbook 2026-06-01 16:04:38
</commit_message>
<xml_diff>
--- a/MeetTeam.pptx
+++ b/MeetTeam.pptx
@@ -5,7 +5,7 @@
     <p:sldMasterId id="2147483684" r:id="rId1"/>
   </p:sldMasterIdLst>
   <p:notesMasterIdLst>
-    <p:notesMasterId r:id="rId12"/>
+    <p:notesMasterId r:id="rId11"/>
   </p:notesMasterIdLst>
   <p:sldIdLst>
     <p:sldId id="256" r:id="rId2"/>
@@ -16,20 +16,19 @@
     <p:sldId id="390" r:id="rId7"/>
     <p:sldId id="391" r:id="rId8"/>
     <p:sldId id="384" r:id="rId9"/>
-    <p:sldId id="393" r:id="rId10"/>
-    <p:sldId id="386" r:id="rId11"/>
+    <p:sldId id="386" r:id="rId10"/>
   </p:sldIdLst>
   <p:sldSz cx="12192000" cy="6858000"/>
   <p:notesSz cx="6858000" cy="9144000"/>
   <p:embeddedFontLst>
     <p:embeddedFont>
       <p:font typeface="Director" pitchFamily="2" charset="0"/>
-      <p:regular r:id="rId13"/>
+      <p:regular r:id="rId12"/>
     </p:embeddedFont>
     <p:embeddedFont>
-      <p:font typeface="Inter" panose="02000503000000020004" pitchFamily="2" charset="0"/>
-      <p:regular r:id="rId14"/>
-      <p:bold r:id="rId15"/>
+      <p:font typeface="Inter" panose="020B0502030000000004" pitchFamily="34" charset="0"/>
+      <p:regular r:id="rId13"/>
+      <p:bold r:id="rId14"/>
     </p:embeddedFont>
   </p:embeddedFontLst>
   <p:defaultTextStyle>
@@ -217,7 +216,7 @@
           <a:p>
             <a:fld id="{7CF2004C-AD6B-4A9A-A490-3730F26EBC0C}" type="datetimeFigureOut">
               <a:rPr lang="en-US" smtClean="0"/>
-              <a:t>6/9/2025</a:t>
+              <a:t>6/1/2026</a:t>
             </a:fld>
             <a:endParaRPr lang="en-US"/>
           </a:p>
@@ -615,7 +614,7 @@
           <a:p>
             <a:fld id="{2E6CAD52-DA28-4E78-92DA-C35A0DBEE03A}" type="datetimeFigureOut">
               <a:rPr lang="en-US" smtClean="0"/>
-              <a:t>6/9/2025</a:t>
+              <a:t>6/1/2026</a:t>
             </a:fld>
             <a:endParaRPr lang="en-US"/>
           </a:p>
@@ -785,7 +784,7 @@
           <a:p>
             <a:fld id="{2E6CAD52-DA28-4E78-92DA-C35A0DBEE03A}" type="datetimeFigureOut">
               <a:rPr lang="en-US" smtClean="0"/>
-              <a:t>6/9/2025</a:t>
+              <a:t>6/1/2026</a:t>
             </a:fld>
             <a:endParaRPr lang="en-US"/>
           </a:p>
@@ -965,7 +964,7 @@
           <a:p>
             <a:fld id="{2E6CAD52-DA28-4E78-92DA-C35A0DBEE03A}" type="datetimeFigureOut">
               <a:rPr lang="en-US" smtClean="0"/>
-              <a:t>6/9/2025</a:t>
+              <a:t>6/1/2026</a:t>
             </a:fld>
             <a:endParaRPr lang="en-US"/>
           </a:p>
@@ -1135,7 +1134,7 @@
           <a:p>
             <a:fld id="{2E6CAD52-DA28-4E78-92DA-C35A0DBEE03A}" type="datetimeFigureOut">
               <a:rPr lang="en-US" smtClean="0"/>
-              <a:t>6/9/2025</a:t>
+              <a:t>6/1/2026</a:t>
             </a:fld>
             <a:endParaRPr lang="en-US"/>
           </a:p>
@@ -1381,7 +1380,7 @@
           <a:p>
             <a:fld id="{2E6CAD52-DA28-4E78-92DA-C35A0DBEE03A}" type="datetimeFigureOut">
               <a:rPr lang="en-US" smtClean="0"/>
-              <a:t>6/9/2025</a:t>
+              <a:t>6/1/2026</a:t>
             </a:fld>
             <a:endParaRPr lang="en-US"/>
           </a:p>
@@ -1613,7 +1612,7 @@
           <a:p>
             <a:fld id="{2E6CAD52-DA28-4E78-92DA-C35A0DBEE03A}" type="datetimeFigureOut">
               <a:rPr lang="en-US" smtClean="0"/>
-              <a:t>6/9/2025</a:t>
+              <a:t>6/1/2026</a:t>
             </a:fld>
             <a:endParaRPr lang="en-US"/>
           </a:p>
@@ -1980,7 +1979,7 @@
           <a:p>
             <a:fld id="{2E6CAD52-DA28-4E78-92DA-C35A0DBEE03A}" type="datetimeFigureOut">
               <a:rPr lang="en-US" smtClean="0"/>
-              <a:t>6/9/2025</a:t>
+              <a:t>6/1/2026</a:t>
             </a:fld>
             <a:endParaRPr lang="en-US"/>
           </a:p>
@@ -2098,7 +2097,7 @@
           <a:p>
             <a:fld id="{2E6CAD52-DA28-4E78-92DA-C35A0DBEE03A}" type="datetimeFigureOut">
               <a:rPr lang="en-US" smtClean="0"/>
-              <a:t>6/9/2025</a:t>
+              <a:t>6/1/2026</a:t>
             </a:fld>
             <a:endParaRPr lang="en-US"/>
           </a:p>
@@ -2193,7 +2192,7 @@
           <a:p>
             <a:fld id="{2E6CAD52-DA28-4E78-92DA-C35A0DBEE03A}" type="datetimeFigureOut">
               <a:rPr lang="en-US" smtClean="0"/>
-              <a:t>6/9/2025</a:t>
+              <a:t>6/1/2026</a:t>
             </a:fld>
             <a:endParaRPr lang="en-US"/>
           </a:p>
@@ -2470,7 +2469,7 @@
           <a:p>
             <a:fld id="{2E6CAD52-DA28-4E78-92DA-C35A0DBEE03A}" type="datetimeFigureOut">
               <a:rPr lang="en-US" smtClean="0"/>
-              <a:t>6/9/2025</a:t>
+              <a:t>6/1/2026</a:t>
             </a:fld>
             <a:endParaRPr lang="en-US"/>
           </a:p>
@@ -2727,7 +2726,7 @@
           <a:p>
             <a:fld id="{2E6CAD52-DA28-4E78-92DA-C35A0DBEE03A}" type="datetimeFigureOut">
               <a:rPr lang="en-US" smtClean="0"/>
-              <a:t>6/9/2025</a:t>
+              <a:t>6/1/2026</a:t>
             </a:fld>
             <a:endParaRPr lang="en-US"/>
           </a:p>
@@ -2940,7 +2939,7 @@
           <a:p>
             <a:fld id="{2E6CAD52-DA28-4E78-92DA-C35A0DBEE03A}" type="datetimeFigureOut">
               <a:rPr lang="en-US" smtClean="0"/>
-              <a:t>6/9/2025</a:t>
+              <a:t>6/1/2026</a:t>
             </a:fld>
             <a:endParaRPr lang="en-US"/>
           </a:p>
@@ -3373,7 +3372,7 @@
           <a:p>
             <a:r>
               <a:rPr lang="en-US" dirty="0"/>
-              <a:t>PEEKE Project 2025</a:t>
+              <a:t>HS Interns 2026</a:t>
             </a:r>
           </a:p>
         </p:txBody>
@@ -3431,97 +3430,6 @@
     <p:extLst>
       <p:ext uri="{BB962C8B-B14F-4D97-AF65-F5344CB8AC3E}">
         <p14:creationId xmlns:p14="http://schemas.microsoft.com/office/powerpoint/2010/main" val="1822262779"/>
-      </p:ext>
-    </p:extLst>
-  </p:cSld>
-  <p:clrMapOvr>
-    <a:masterClrMapping/>
-  </p:clrMapOvr>
-</p:sld>
-</file>
-
-<file path=ppt/slides/slide10.xml><?xml version="1.0" encoding="utf-8"?>
-<p:sld xmlns:a="http://schemas.openxmlformats.org/drawingml/2006/main" xmlns:r="http://schemas.openxmlformats.org/officeDocument/2006/relationships" xmlns:p="http://schemas.openxmlformats.org/presentationml/2006/main">
-  <p:cSld>
-    <p:spTree>
-      <p:nvGrpSpPr>
-        <p:cNvPr id="1" name=""/>
-        <p:cNvGrpSpPr/>
-        <p:nvPr/>
-      </p:nvGrpSpPr>
-      <p:grpSpPr>
-        <a:xfrm>
-          <a:off x="0" y="0"/>
-          <a:ext cx="0" cy="0"/>
-          <a:chOff x="0" y="0"/>
-          <a:chExt cx="0" cy="0"/>
-        </a:xfrm>
-      </p:grpSpPr>
-      <p:sp>
-        <p:nvSpPr>
-          <p:cNvPr id="2" name="Title 1">
-            <a:extLst>
-              <a:ext uri="{FF2B5EF4-FFF2-40B4-BE49-F238E27FC236}">
-                <a16:creationId xmlns:a16="http://schemas.microsoft.com/office/drawing/2014/main" id="{01F9C0DC-B238-3823-59FF-55A5FC4212E1}"/>
-              </a:ext>
-            </a:extLst>
-          </p:cNvPr>
-          <p:cNvSpPr>
-            <a:spLocks noGrp="1"/>
-          </p:cNvSpPr>
-          <p:nvPr>
-            <p:ph type="title"/>
-          </p:nvPr>
-        </p:nvSpPr>
-        <p:spPr/>
-        <p:txBody>
-          <a:bodyPr/>
-          <a:lstStyle/>
-          <a:p>
-            <a:r>
-              <a:rPr lang="en-US" dirty="0"/>
-              <a:t>THANK YOU</a:t>
-            </a:r>
-          </a:p>
-        </p:txBody>
-      </p:sp>
-      <p:sp>
-        <p:nvSpPr>
-          <p:cNvPr id="3" name="Text Placeholder 2">
-            <a:extLst>
-              <a:ext uri="{FF2B5EF4-FFF2-40B4-BE49-F238E27FC236}">
-                <a16:creationId xmlns:a16="http://schemas.microsoft.com/office/drawing/2014/main" id="{13F25B73-B2E7-9DC4-7B36-887C5D620742}"/>
-              </a:ext>
-            </a:extLst>
-          </p:cNvPr>
-          <p:cNvSpPr>
-            <a:spLocks noGrp="1"/>
-          </p:cNvSpPr>
-          <p:nvPr>
-            <p:ph type="body" idx="1"/>
-          </p:nvPr>
-        </p:nvSpPr>
-        <p:spPr/>
-        <p:txBody>
-          <a:bodyPr/>
-          <a:lstStyle/>
-          <a:p>
-            <a:r>
-              <a:rPr lang="en-US" i="1" dirty="0"/>
-              <a:t>lunch </a:t>
-            </a:r>
-            <a:r>
-              <a:rPr lang="en-US" i="1"/>
-              <a:t>is next!</a:t>
-            </a:r>
-            <a:endParaRPr lang="en-US" i="1" dirty="0"/>
-          </a:p>
-        </p:txBody>
-      </p:sp>
-    </p:spTree>
-    <p:extLst>
-      <p:ext uri="{BB962C8B-B14F-4D97-AF65-F5344CB8AC3E}">
-        <p14:creationId xmlns:p14="http://schemas.microsoft.com/office/powerpoint/2010/main" val="271307970"/>
       </p:ext>
     </p:extLst>
   </p:cSld>
@@ -3777,7 +3685,19 @@
               <a:rPr lang="en-US" sz="3200" dirty="0">
                 <a:hlinkClick r:id="rId2"/>
               </a:rPr>
-              <a:t>hylandtechoutreach.github.io/peeke-internship-2025</a:t>
+              <a:t>hylandtechoutreach.github.io/</a:t>
+            </a:r>
+            <a:r>
+              <a:rPr lang="en-US" sz="3200" dirty="0" err="1">
+                <a:hlinkClick r:id="rId2"/>
+              </a:rPr>
+              <a:t>hs</a:t>
+            </a:r>
+            <a:r>
+              <a:rPr lang="en-US" sz="3200" dirty="0">
+                <a:hlinkClick r:id="rId2"/>
+              </a:rPr>
+              <a:t>-internship</a:t>
             </a:r>
             <a:endParaRPr lang="en-US" sz="3200" dirty="0"/>
           </a:p>
@@ -4437,14 +4357,14 @@
             <p:ph idx="1"/>
             <p:extLst>
               <p:ext uri="{D42A27DB-BD31-4B8C-83A1-F6EECF244321}">
-                <p14:modId xmlns:p14="http://schemas.microsoft.com/office/powerpoint/2010/main" val="1455492509"/>
+                <p14:modId xmlns:p14="http://schemas.microsoft.com/office/powerpoint/2010/main" val="516400332"/>
               </p:ext>
             </p:extLst>
           </p:nvPr>
         </p:nvGraphicFramePr>
         <p:xfrm>
           <a:off x="838200" y="1690688"/>
-          <a:ext cx="10515600" cy="4329144"/>
+          <a:ext cx="10515600" cy="3607620"/>
         </p:xfrm>
         <a:graphic>
           <a:graphicData uri="http://schemas.openxmlformats.org/drawingml/2006/table">
@@ -4617,42 +4537,7 @@
                       <a:pPr algn="ctr"/>
                       <a:r>
                         <a:rPr lang="en-US" sz="2800" dirty="0"/>
-                        <a:t>2:00pm-2:30pm</a:t>
-                      </a:r>
-                    </a:p>
-                  </a:txBody>
-                  <a:tcPr anchor="ctr"/>
-                </a:tc>
-                <a:tc>
-                  <a:txBody>
-                    <a:bodyPr/>
-                    <a:lstStyle/>
-                    <a:p>
-                      <a:pPr algn="ctr"/>
-                      <a:r>
-                        <a:rPr lang="en-US" sz="2800" dirty="0"/>
-                        <a:t>Tech Outreach Team Meeting</a:t>
-                      </a:r>
-                    </a:p>
-                  </a:txBody>
-                  <a:tcPr anchor="ctr"/>
-                </a:tc>
-                <a:extLst>
-                  <a:ext uri="{0D108BD9-81ED-4DB2-BD59-A6C34878D82A}">
-                    <a16:rowId xmlns:a16="http://schemas.microsoft.com/office/drawing/2014/main" val="2971069475"/>
-                  </a:ext>
-                </a:extLst>
-              </a:tr>
-              <a:tr h="721524">
-                <a:tc>
-                  <a:txBody>
-                    <a:bodyPr/>
-                    <a:lstStyle/>
-                    <a:p>
-                      <a:pPr algn="ctr"/>
-                      <a:r>
-                        <a:rPr lang="en-US" sz="2800" dirty="0"/>
-                        <a:t>2:30pm-4:00pm</a:t>
+                        <a:t>2:00pm-4:00pm</a:t>
                       </a:r>
                     </a:p>
                   </a:txBody>
@@ -4814,602 +4699,69 @@
       </p:grpSpPr>
       <p:sp>
         <p:nvSpPr>
-          <p:cNvPr id="3" name="TextBox 2">
+          <p:cNvPr id="2" name="Title 1">
             <a:extLst>
               <a:ext uri="{FF2B5EF4-FFF2-40B4-BE49-F238E27FC236}">
-                <a16:creationId xmlns:a16="http://schemas.microsoft.com/office/drawing/2014/main" id="{4DD078B1-774A-E2CA-DDD3-924CFDB12040}"/>
+                <a16:creationId xmlns:a16="http://schemas.microsoft.com/office/drawing/2014/main" id="{01F9C0DC-B238-3823-59FF-55A5FC4212E1}"/>
               </a:ext>
             </a:extLst>
           </p:cNvPr>
-          <p:cNvSpPr txBox="1"/>
-          <p:nvPr/>
-        </p:nvSpPr>
-        <p:spPr>
-          <a:xfrm>
-            <a:off x="426720" y="1762805"/>
-            <a:ext cx="5303520" cy="3332387"/>
-          </a:xfrm>
-          <a:prstGeom prst="rect">
-            <a:avLst/>
-          </a:prstGeom>
-          <a:noFill/>
-        </p:spPr>
-        <p:txBody>
-          <a:bodyPr wrap="square">
-            <a:spAutoFit/>
-          </a:bodyPr>
-          <a:lstStyle/>
-          <a:p>
-            <a:pPr marL="342900" marR="0" lvl="0" indent="-342900">
-              <a:lnSpc>
-                <a:spcPts val="3200"/>
-              </a:lnSpc>
-              <a:spcBef>
-                <a:spcPts val="0"/>
-              </a:spcBef>
-              <a:spcAft>
-                <a:spcPts val="0"/>
-              </a:spcAft>
-              <a:buFont typeface="Wingdings" panose="05000000000000000000" pitchFamily="2" charset="2"/>
-              <a:buChar char=""/>
-            </a:pPr>
-            <a:r>
-              <a:rPr lang="en-US" sz="1800" dirty="0">
-                <a:effectLst/>
-                <a:latin typeface="Inter" panose="02000503000000020004" pitchFamily="2" charset="0"/>
-                <a:ea typeface="Calibri" panose="020F0502020204030204" pitchFamily="34" charset="0"/>
-                <a:cs typeface="Times New Roman" panose="02020603050405020304" pitchFamily="18" charset="0"/>
-              </a:rPr>
-              <a:t>Visit the internship homepage</a:t>
-            </a:r>
-            <a:endParaRPr lang="en-US" sz="1400" dirty="0">
-              <a:effectLst/>
-              <a:latin typeface="Calibri" panose="020F0502020204030204" pitchFamily="34" charset="0"/>
-              <a:ea typeface="Calibri" panose="020F0502020204030204" pitchFamily="34" charset="0"/>
-              <a:cs typeface="Times New Roman" panose="02020603050405020304" pitchFamily="18" charset="0"/>
-            </a:endParaRPr>
-          </a:p>
-          <a:p>
-            <a:pPr marL="342900" marR="0" lvl="0" indent="-342900">
-              <a:lnSpc>
-                <a:spcPts val="3200"/>
-              </a:lnSpc>
-              <a:spcBef>
-                <a:spcPts val="0"/>
-              </a:spcBef>
-              <a:spcAft>
-                <a:spcPts val="0"/>
-              </a:spcAft>
-              <a:buFont typeface="Wingdings" panose="05000000000000000000" pitchFamily="2" charset="2"/>
-              <a:buChar char=""/>
-            </a:pPr>
-            <a:r>
-              <a:rPr lang="en-US" sz="1800" dirty="0">
-                <a:effectLst/>
-                <a:latin typeface="Inter" panose="02000503000000020004" pitchFamily="2" charset="0"/>
-                <a:ea typeface="Calibri" panose="020F0502020204030204" pitchFamily="34" charset="0"/>
-                <a:cs typeface="Times New Roman" panose="02020603050405020304" pitchFamily="18" charset="0"/>
-              </a:rPr>
-              <a:t>Change your desktop background</a:t>
-            </a:r>
-            <a:endParaRPr lang="en-US" sz="1400" dirty="0">
-              <a:effectLst/>
-              <a:latin typeface="Calibri" panose="020F0502020204030204" pitchFamily="34" charset="0"/>
-              <a:ea typeface="Calibri" panose="020F0502020204030204" pitchFamily="34" charset="0"/>
-              <a:cs typeface="Times New Roman" panose="02020603050405020304" pitchFamily="18" charset="0"/>
-            </a:endParaRPr>
-          </a:p>
-          <a:p>
-            <a:pPr marL="342900" marR="0" lvl="0" indent="-342900">
-              <a:lnSpc>
-                <a:spcPts val="3200"/>
-              </a:lnSpc>
-              <a:spcBef>
-                <a:spcPts val="0"/>
-              </a:spcBef>
-              <a:spcAft>
-                <a:spcPts val="0"/>
-              </a:spcAft>
-              <a:buFont typeface="Wingdings" panose="05000000000000000000" pitchFamily="2" charset="2"/>
-              <a:buChar char=""/>
-            </a:pPr>
-            <a:r>
-              <a:rPr lang="en-US" sz="1800" dirty="0">
-                <a:effectLst/>
-                <a:latin typeface="Inter" panose="02000503000000020004" pitchFamily="2" charset="0"/>
-                <a:ea typeface="Calibri" panose="020F0502020204030204" pitchFamily="34" charset="0"/>
-                <a:cs typeface="Times New Roman" panose="02020603050405020304" pitchFamily="18" charset="0"/>
-              </a:rPr>
-              <a:t>Play a game of ping pong</a:t>
-            </a:r>
-            <a:endParaRPr lang="en-US" sz="1400" dirty="0">
-              <a:effectLst/>
-              <a:latin typeface="Calibri" panose="020F0502020204030204" pitchFamily="34" charset="0"/>
-              <a:ea typeface="Calibri" panose="020F0502020204030204" pitchFamily="34" charset="0"/>
-              <a:cs typeface="Times New Roman" panose="02020603050405020304" pitchFamily="18" charset="0"/>
-            </a:endParaRPr>
-          </a:p>
-          <a:p>
-            <a:pPr marL="342900" marR="0" lvl="0" indent="-342900">
-              <a:lnSpc>
-                <a:spcPts val="3200"/>
-              </a:lnSpc>
-              <a:spcBef>
-                <a:spcPts val="0"/>
-              </a:spcBef>
-              <a:spcAft>
-                <a:spcPts val="0"/>
-              </a:spcAft>
-              <a:buFont typeface="Wingdings" panose="05000000000000000000" pitchFamily="2" charset="2"/>
-              <a:buChar char=""/>
-            </a:pPr>
-            <a:r>
-              <a:rPr lang="en-US" sz="1800" dirty="0">
-                <a:effectLst/>
-                <a:latin typeface="Inter" panose="02000503000000020004" pitchFamily="2" charset="0"/>
-                <a:ea typeface="Calibri" panose="020F0502020204030204" pitchFamily="34" charset="0"/>
-                <a:cs typeface="Times New Roman" panose="02020603050405020304" pitchFamily="18" charset="0"/>
-              </a:rPr>
-              <a:t>Watch a video from the Fun Things page</a:t>
-            </a:r>
-            <a:endParaRPr lang="en-US" sz="1400" dirty="0">
-              <a:effectLst/>
-              <a:latin typeface="Calibri" panose="020F0502020204030204" pitchFamily="34" charset="0"/>
-              <a:ea typeface="Calibri" panose="020F0502020204030204" pitchFamily="34" charset="0"/>
-              <a:cs typeface="Times New Roman" panose="02020603050405020304" pitchFamily="18" charset="0"/>
-            </a:endParaRPr>
-          </a:p>
-          <a:p>
-            <a:pPr marL="342900" marR="0" lvl="0" indent="-342900">
-              <a:lnSpc>
-                <a:spcPts val="3200"/>
-              </a:lnSpc>
-              <a:spcBef>
-                <a:spcPts val="0"/>
-              </a:spcBef>
-              <a:spcAft>
-                <a:spcPts val="0"/>
-              </a:spcAft>
-              <a:buFont typeface="Wingdings" panose="05000000000000000000" pitchFamily="2" charset="2"/>
-              <a:buChar char=""/>
-            </a:pPr>
-            <a:r>
-              <a:rPr lang="en-US" sz="1800" dirty="0">
-                <a:effectLst/>
-                <a:latin typeface="Inter" panose="02000503000000020004" pitchFamily="2" charset="0"/>
-                <a:ea typeface="Calibri" panose="020F0502020204030204" pitchFamily="34" charset="0"/>
-                <a:cs typeface="Times New Roman" panose="02020603050405020304" pitchFamily="18" charset="0"/>
-              </a:rPr>
-              <a:t>Complete one of the learning path items</a:t>
-            </a:r>
-            <a:endParaRPr lang="en-US" sz="1400" dirty="0">
-              <a:effectLst/>
-              <a:latin typeface="Calibri" panose="020F0502020204030204" pitchFamily="34" charset="0"/>
-              <a:ea typeface="Calibri" panose="020F0502020204030204" pitchFamily="34" charset="0"/>
-              <a:cs typeface="Times New Roman" panose="02020603050405020304" pitchFamily="18" charset="0"/>
-            </a:endParaRPr>
-          </a:p>
-          <a:p>
-            <a:pPr marL="342900" marR="0" lvl="0" indent="-342900">
-              <a:lnSpc>
-                <a:spcPts val="3200"/>
-              </a:lnSpc>
-              <a:spcBef>
-                <a:spcPts val="0"/>
-              </a:spcBef>
-              <a:spcAft>
-                <a:spcPts val="0"/>
-              </a:spcAft>
-              <a:buFont typeface="Wingdings" panose="05000000000000000000" pitchFamily="2" charset="2"/>
-              <a:buChar char=""/>
-            </a:pPr>
-            <a:r>
-              <a:rPr lang="en-US" sz="1800" dirty="0">
-                <a:effectLst/>
-                <a:latin typeface="Inter" panose="02000503000000020004" pitchFamily="2" charset="0"/>
-                <a:ea typeface="Calibri" panose="020F0502020204030204" pitchFamily="34" charset="0"/>
-                <a:cs typeface="Times New Roman" panose="02020603050405020304" pitchFamily="18" charset="0"/>
-              </a:rPr>
-              <a:t>Work somewhere other than your desk</a:t>
-            </a:r>
-            <a:endParaRPr lang="en-US" sz="1400" dirty="0">
-              <a:effectLst/>
-              <a:latin typeface="Calibri" panose="020F0502020204030204" pitchFamily="34" charset="0"/>
-              <a:ea typeface="Calibri" panose="020F0502020204030204" pitchFamily="34" charset="0"/>
-              <a:cs typeface="Times New Roman" panose="02020603050405020304" pitchFamily="18" charset="0"/>
-            </a:endParaRPr>
-          </a:p>
-          <a:p>
-            <a:pPr marL="342900" marR="0" lvl="0" indent="-342900">
-              <a:lnSpc>
-                <a:spcPts val="3200"/>
-              </a:lnSpc>
-              <a:spcBef>
-                <a:spcPts val="0"/>
-              </a:spcBef>
-              <a:spcAft>
-                <a:spcPts val="0"/>
-              </a:spcAft>
-              <a:buFont typeface="Wingdings" panose="05000000000000000000" pitchFamily="2" charset="2"/>
-              <a:buChar char=""/>
-            </a:pPr>
-            <a:r>
-              <a:rPr lang="en-US" sz="1800" dirty="0">
-                <a:effectLst/>
-                <a:latin typeface="Inter" panose="02000503000000020004" pitchFamily="2" charset="0"/>
-                <a:ea typeface="Calibri" panose="020F0502020204030204" pitchFamily="34" charset="0"/>
-                <a:cs typeface="Times New Roman" panose="02020603050405020304" pitchFamily="18" charset="0"/>
-              </a:rPr>
-              <a:t>Send an email from your work account</a:t>
-            </a:r>
-            <a:endParaRPr lang="en-US" sz="1400" dirty="0">
-              <a:effectLst/>
-              <a:latin typeface="Calibri" panose="020F0502020204030204" pitchFamily="34" charset="0"/>
-              <a:ea typeface="Calibri" panose="020F0502020204030204" pitchFamily="34" charset="0"/>
-              <a:cs typeface="Times New Roman" panose="02020603050405020304" pitchFamily="18" charset="0"/>
-            </a:endParaRPr>
-          </a:p>
-          <a:p>
-            <a:pPr marL="342900" marR="0" lvl="0" indent="-342900">
-              <a:lnSpc>
-                <a:spcPts val="3200"/>
-              </a:lnSpc>
-              <a:spcBef>
-                <a:spcPts val="0"/>
-              </a:spcBef>
-              <a:spcAft>
-                <a:spcPts val="0"/>
-              </a:spcAft>
-              <a:buFont typeface="Wingdings" panose="05000000000000000000" pitchFamily="2" charset="2"/>
-              <a:buChar char=""/>
-            </a:pPr>
-            <a:r>
-              <a:rPr lang="en-US" sz="1800" dirty="0">
-                <a:effectLst/>
-                <a:latin typeface="Inter" panose="02000503000000020004" pitchFamily="2" charset="0"/>
-                <a:ea typeface="Calibri" panose="020F0502020204030204" pitchFamily="34" charset="0"/>
-                <a:cs typeface="Times New Roman" panose="02020603050405020304" pitchFamily="18" charset="0"/>
-              </a:rPr>
-              <a:t>Run the </a:t>
-            </a:r>
-            <a:r>
-              <a:rPr lang="en-US" sz="1800" dirty="0" err="1">
-                <a:effectLst/>
-                <a:latin typeface="Inter" panose="02000503000000020004" pitchFamily="2" charset="0"/>
-                <a:ea typeface="Calibri" panose="020F0502020204030204" pitchFamily="34" charset="0"/>
-                <a:cs typeface="Times New Roman" panose="02020603050405020304" pitchFamily="18" charset="0"/>
-              </a:rPr>
-              <a:t>HyTOP</a:t>
-            </a:r>
-            <a:r>
-              <a:rPr lang="en-US" sz="1800" dirty="0">
-                <a:effectLst/>
-                <a:latin typeface="Inter" panose="02000503000000020004" pitchFamily="2" charset="0"/>
-                <a:ea typeface="Calibri" panose="020F0502020204030204" pitchFamily="34" charset="0"/>
-                <a:cs typeface="Times New Roman" panose="02020603050405020304" pitchFamily="18" charset="0"/>
-              </a:rPr>
-              <a:t> application locally</a:t>
-            </a:r>
-            <a:endParaRPr lang="en-US" sz="1400" dirty="0">
-              <a:effectLst/>
-              <a:latin typeface="Calibri" panose="020F0502020204030204" pitchFamily="34" charset="0"/>
-              <a:ea typeface="Calibri" panose="020F0502020204030204" pitchFamily="34" charset="0"/>
-              <a:cs typeface="Times New Roman" panose="02020603050405020304" pitchFamily="18" charset="0"/>
-            </a:endParaRPr>
-          </a:p>
-        </p:txBody>
-      </p:sp>
-      <p:sp>
-        <p:nvSpPr>
-          <p:cNvPr id="7" name="TextBox 6">
+          <p:cNvSpPr>
+            <a:spLocks noGrp="1"/>
+          </p:cNvSpPr>
+          <p:nvPr>
+            <p:ph type="title"/>
+          </p:nvPr>
+        </p:nvSpPr>
+        <p:spPr/>
+        <p:txBody>
+          <a:bodyPr/>
+          <a:lstStyle/>
+          <a:p>
+            <a:r>
+              <a:rPr lang="en-US" dirty="0"/>
+              <a:t>THANK YOU</a:t>
+            </a:r>
+          </a:p>
+        </p:txBody>
+      </p:sp>
+      <p:sp>
+        <p:nvSpPr>
+          <p:cNvPr id="3" name="Text Placeholder 2">
             <a:extLst>
               <a:ext uri="{FF2B5EF4-FFF2-40B4-BE49-F238E27FC236}">
-                <a16:creationId xmlns:a16="http://schemas.microsoft.com/office/drawing/2014/main" id="{BAF0AA05-6D55-8E35-1081-11689BC6B6D3}"/>
+                <a16:creationId xmlns:a16="http://schemas.microsoft.com/office/drawing/2014/main" id="{13F25B73-B2E7-9DC4-7B36-887C5D620742}"/>
               </a:ext>
             </a:extLst>
           </p:cNvPr>
-          <p:cNvSpPr txBox="1"/>
-          <p:nvPr/>
-        </p:nvSpPr>
-        <p:spPr>
-          <a:xfrm>
-            <a:off x="5730240" y="1557621"/>
-            <a:ext cx="6461760" cy="3742756"/>
-          </a:xfrm>
-          <a:prstGeom prst="rect">
-            <a:avLst/>
-          </a:prstGeom>
-          <a:noFill/>
-        </p:spPr>
-        <p:txBody>
-          <a:bodyPr wrap="square">
-            <a:spAutoFit/>
-          </a:bodyPr>
-          <a:lstStyle/>
-          <a:p>
-            <a:pPr marL="342900" marR="0" lvl="0" indent="-342900">
-              <a:lnSpc>
-                <a:spcPts val="3200"/>
-              </a:lnSpc>
-              <a:spcBef>
-                <a:spcPts val="0"/>
-              </a:spcBef>
-              <a:spcAft>
-                <a:spcPts val="0"/>
-              </a:spcAft>
-              <a:buFont typeface="Wingdings" panose="05000000000000000000" pitchFamily="2" charset="2"/>
-              <a:buChar char=""/>
-            </a:pPr>
-            <a:r>
-              <a:rPr lang="en-US" sz="1800" dirty="0">
-                <a:effectLst/>
-                <a:latin typeface="Inter" panose="02000503000000020004" pitchFamily="2" charset="0"/>
-                <a:ea typeface="Calibri" panose="020F0502020204030204" pitchFamily="34" charset="0"/>
-                <a:cs typeface="Times New Roman" panose="02020603050405020304" pitchFamily="18" charset="0"/>
-              </a:rPr>
-              <a:t>Practice pair programming</a:t>
-            </a:r>
-            <a:endParaRPr lang="en-US" sz="1400" dirty="0">
-              <a:effectLst/>
-              <a:latin typeface="Calibri" panose="020F0502020204030204" pitchFamily="34" charset="0"/>
-              <a:ea typeface="Calibri" panose="020F0502020204030204" pitchFamily="34" charset="0"/>
-              <a:cs typeface="Times New Roman" panose="02020603050405020304" pitchFamily="18" charset="0"/>
-            </a:endParaRPr>
-          </a:p>
-          <a:p>
-            <a:pPr marL="342900" marR="0" lvl="0" indent="-342900">
-              <a:lnSpc>
-                <a:spcPts val="3200"/>
-              </a:lnSpc>
-              <a:spcBef>
-                <a:spcPts val="0"/>
-              </a:spcBef>
-              <a:spcAft>
-                <a:spcPts val="0"/>
-              </a:spcAft>
-              <a:buFont typeface="Wingdings" panose="05000000000000000000" pitchFamily="2" charset="2"/>
-              <a:buChar char=""/>
-            </a:pPr>
-            <a:r>
-              <a:rPr lang="en-US" sz="1800" dirty="0">
-                <a:effectLst/>
-                <a:latin typeface="Inter" panose="02000503000000020004" pitchFamily="2" charset="0"/>
-                <a:ea typeface="Calibri" panose="020F0502020204030204" pitchFamily="34" charset="0"/>
-                <a:cs typeface="Times New Roman" panose="02020603050405020304" pitchFamily="18" charset="0"/>
-              </a:rPr>
-              <a:t>Grab some pretzels, M&amp;Ms, or mints</a:t>
-            </a:r>
-            <a:endParaRPr lang="en-US" sz="1400" dirty="0">
-              <a:effectLst/>
-              <a:latin typeface="Calibri" panose="020F0502020204030204" pitchFamily="34" charset="0"/>
-              <a:ea typeface="Calibri" panose="020F0502020204030204" pitchFamily="34" charset="0"/>
-              <a:cs typeface="Times New Roman" panose="02020603050405020304" pitchFamily="18" charset="0"/>
-            </a:endParaRPr>
-          </a:p>
-          <a:p>
-            <a:pPr marL="342900" marR="0" lvl="0" indent="-342900">
-              <a:lnSpc>
-                <a:spcPts val="3200"/>
-              </a:lnSpc>
-              <a:spcBef>
-                <a:spcPts val="0"/>
-              </a:spcBef>
-              <a:spcAft>
-                <a:spcPts val="0"/>
-              </a:spcAft>
-              <a:buFont typeface="Wingdings" panose="05000000000000000000" pitchFamily="2" charset="2"/>
-              <a:buChar char=""/>
-            </a:pPr>
-            <a:r>
-              <a:rPr lang="en-US" sz="1800" dirty="0">
-                <a:effectLst/>
-                <a:latin typeface="Inter" panose="02000503000000020004" pitchFamily="2" charset="0"/>
-                <a:ea typeface="Calibri" panose="020F0502020204030204" pitchFamily="34" charset="0"/>
-                <a:cs typeface="Times New Roman" panose="02020603050405020304" pitchFamily="18" charset="0"/>
-              </a:rPr>
-              <a:t>Send a Teams message to another intern</a:t>
-            </a:r>
-            <a:endParaRPr lang="en-US" sz="1400" dirty="0">
-              <a:effectLst/>
-              <a:latin typeface="Calibri" panose="020F0502020204030204" pitchFamily="34" charset="0"/>
-              <a:ea typeface="Calibri" panose="020F0502020204030204" pitchFamily="34" charset="0"/>
-              <a:cs typeface="Times New Roman" panose="02020603050405020304" pitchFamily="18" charset="0"/>
-            </a:endParaRPr>
-          </a:p>
-          <a:p>
-            <a:pPr marL="342900" marR="0" lvl="0" indent="-342900">
-              <a:lnSpc>
-                <a:spcPts val="3200"/>
-              </a:lnSpc>
-              <a:spcBef>
-                <a:spcPts val="0"/>
-              </a:spcBef>
-              <a:spcAft>
-                <a:spcPts val="0"/>
-              </a:spcAft>
-              <a:buFont typeface="Wingdings" panose="05000000000000000000" pitchFamily="2" charset="2"/>
-              <a:buChar char=""/>
-            </a:pPr>
-            <a:r>
-              <a:rPr lang="en-US" sz="1800" dirty="0">
-                <a:effectLst/>
-                <a:latin typeface="Inter" panose="02000503000000020004" pitchFamily="2" charset="0"/>
-                <a:ea typeface="Calibri" panose="020F0502020204030204" pitchFamily="34" charset="0"/>
-                <a:cs typeface="Times New Roman" panose="02020603050405020304" pitchFamily="18" charset="0"/>
-              </a:rPr>
-              <a:t>Run into a problem</a:t>
-            </a:r>
-            <a:endParaRPr lang="en-US" sz="1400" dirty="0">
-              <a:effectLst/>
-              <a:latin typeface="Calibri" panose="020F0502020204030204" pitchFamily="34" charset="0"/>
-              <a:ea typeface="Calibri" panose="020F0502020204030204" pitchFamily="34" charset="0"/>
-              <a:cs typeface="Times New Roman" panose="02020603050405020304" pitchFamily="18" charset="0"/>
-            </a:endParaRPr>
-          </a:p>
-          <a:p>
-            <a:pPr marL="342900" marR="0" lvl="0" indent="-342900">
-              <a:lnSpc>
-                <a:spcPts val="3200"/>
-              </a:lnSpc>
-              <a:spcBef>
-                <a:spcPts val="0"/>
-              </a:spcBef>
-              <a:spcAft>
-                <a:spcPts val="0"/>
-              </a:spcAft>
-              <a:buFont typeface="Wingdings" panose="05000000000000000000" pitchFamily="2" charset="2"/>
-              <a:buChar char=""/>
-            </a:pPr>
-            <a:r>
-              <a:rPr lang="en-US" sz="1800" dirty="0">
-                <a:effectLst/>
-                <a:latin typeface="Inter" panose="02000503000000020004" pitchFamily="2" charset="0"/>
-                <a:ea typeface="Calibri" panose="020F0502020204030204" pitchFamily="34" charset="0"/>
-                <a:cs typeface="Times New Roman" panose="02020603050405020304" pitchFamily="18" charset="0"/>
-              </a:rPr>
-              <a:t>Adorn your desk with a decorative item of some kind</a:t>
-            </a:r>
-            <a:endParaRPr lang="en-US" sz="1400" dirty="0">
-              <a:effectLst/>
-              <a:latin typeface="Calibri" panose="020F0502020204030204" pitchFamily="34" charset="0"/>
-              <a:ea typeface="Calibri" panose="020F0502020204030204" pitchFamily="34" charset="0"/>
-              <a:cs typeface="Times New Roman" panose="02020603050405020304" pitchFamily="18" charset="0"/>
-            </a:endParaRPr>
-          </a:p>
-          <a:p>
-            <a:pPr marL="342900" marR="0" lvl="0" indent="-342900">
-              <a:lnSpc>
-                <a:spcPts val="3200"/>
-              </a:lnSpc>
-              <a:spcBef>
-                <a:spcPts val="0"/>
-              </a:spcBef>
-              <a:spcAft>
-                <a:spcPts val="0"/>
-              </a:spcAft>
-              <a:buFont typeface="Wingdings" panose="05000000000000000000" pitchFamily="2" charset="2"/>
-              <a:buChar char=""/>
-            </a:pPr>
-            <a:r>
-              <a:rPr lang="en-US" sz="1800" dirty="0">
-                <a:effectLst/>
-                <a:latin typeface="Inter" panose="02000503000000020004" pitchFamily="2" charset="0"/>
-                <a:ea typeface="Calibri" panose="020F0502020204030204" pitchFamily="34" charset="0"/>
-                <a:cs typeface="Times New Roman" panose="02020603050405020304" pitchFamily="18" charset="0"/>
-              </a:rPr>
-              <a:t>Hack the password protected page</a:t>
-            </a:r>
-            <a:endParaRPr lang="en-US" sz="1400" dirty="0">
-              <a:effectLst/>
-              <a:latin typeface="Calibri" panose="020F0502020204030204" pitchFamily="34" charset="0"/>
-              <a:ea typeface="Calibri" panose="020F0502020204030204" pitchFamily="34" charset="0"/>
-              <a:cs typeface="Times New Roman" panose="02020603050405020304" pitchFamily="18" charset="0"/>
-            </a:endParaRPr>
-          </a:p>
-          <a:p>
-            <a:pPr marL="342900" marR="0" lvl="0" indent="-342900">
-              <a:lnSpc>
-                <a:spcPts val="3200"/>
-              </a:lnSpc>
-              <a:spcBef>
-                <a:spcPts val="0"/>
-              </a:spcBef>
-              <a:spcAft>
-                <a:spcPts val="0"/>
-              </a:spcAft>
-              <a:buFont typeface="Wingdings" panose="05000000000000000000" pitchFamily="2" charset="2"/>
-              <a:buChar char=""/>
-            </a:pPr>
-            <a:r>
-              <a:rPr lang="en-US" sz="1800" dirty="0">
-                <a:effectLst/>
-                <a:latin typeface="Inter" panose="02000503000000020004" pitchFamily="2" charset="0"/>
-                <a:ea typeface="Calibri" panose="020F0502020204030204" pitchFamily="34" charset="0"/>
-                <a:cs typeface="Times New Roman" panose="02020603050405020304" pitchFamily="18" charset="0"/>
-              </a:rPr>
-              <a:t>Practice mob programming</a:t>
-            </a:r>
-            <a:endParaRPr lang="en-US" sz="1400" dirty="0">
-              <a:effectLst/>
-              <a:latin typeface="Calibri" panose="020F0502020204030204" pitchFamily="34" charset="0"/>
-              <a:ea typeface="Calibri" panose="020F0502020204030204" pitchFamily="34" charset="0"/>
-              <a:cs typeface="Times New Roman" panose="02020603050405020304" pitchFamily="18" charset="0"/>
-            </a:endParaRPr>
-          </a:p>
-          <a:p>
-            <a:pPr marL="342900" marR="0" lvl="0" indent="-342900">
-              <a:lnSpc>
-                <a:spcPts val="3200"/>
-              </a:lnSpc>
-              <a:spcBef>
-                <a:spcPts val="0"/>
-              </a:spcBef>
-              <a:spcAft>
-                <a:spcPts val="0"/>
-              </a:spcAft>
-              <a:buFont typeface="Wingdings" panose="05000000000000000000" pitchFamily="2" charset="2"/>
-              <a:buChar char=""/>
-            </a:pPr>
-            <a:r>
-              <a:rPr lang="en-US" sz="1800" dirty="0">
-                <a:effectLst/>
-                <a:latin typeface="Inter" panose="02000503000000020004" pitchFamily="2" charset="0"/>
-                <a:ea typeface="Calibri" panose="020F0502020204030204" pitchFamily="34" charset="0"/>
-                <a:cs typeface="Times New Roman" panose="02020603050405020304" pitchFamily="18" charset="0"/>
-              </a:rPr>
-              <a:t>Get free </a:t>
-            </a:r>
-            <a:r>
-              <a:rPr lang="en-US" dirty="0">
-                <a:latin typeface="Inter" panose="02000503000000020004" pitchFamily="2" charset="0"/>
-                <a:ea typeface="Calibri" panose="020F0502020204030204" pitchFamily="34" charset="0"/>
-                <a:cs typeface="Times New Roman" panose="02020603050405020304" pitchFamily="18" charset="0"/>
-              </a:rPr>
-              <a:t>lunch</a:t>
-            </a:r>
-            <a:endParaRPr lang="en-US" sz="1400" dirty="0">
-              <a:effectLst/>
-              <a:latin typeface="Calibri" panose="020F0502020204030204" pitchFamily="34" charset="0"/>
-              <a:ea typeface="Calibri" panose="020F0502020204030204" pitchFamily="34" charset="0"/>
-              <a:cs typeface="Times New Roman" panose="02020603050405020304" pitchFamily="18" charset="0"/>
-            </a:endParaRPr>
-          </a:p>
-          <a:p>
-            <a:pPr marL="342900" marR="0" lvl="0" indent="-342900">
-              <a:lnSpc>
-                <a:spcPts val="3200"/>
-              </a:lnSpc>
-              <a:spcBef>
-                <a:spcPts val="0"/>
-              </a:spcBef>
-              <a:spcAft>
-                <a:spcPts val="800"/>
-              </a:spcAft>
-              <a:buFont typeface="Wingdings" panose="05000000000000000000" pitchFamily="2" charset="2"/>
-              <a:buChar char=""/>
-            </a:pPr>
-            <a:r>
-              <a:rPr lang="en-US" sz="1800" dirty="0">
-                <a:effectLst/>
-                <a:latin typeface="Inter" panose="02000503000000020004" pitchFamily="2" charset="0"/>
-                <a:ea typeface="Calibri" panose="020F0502020204030204" pitchFamily="34" charset="0"/>
-                <a:cs typeface="Times New Roman" panose="02020603050405020304" pitchFamily="18" charset="0"/>
-              </a:rPr>
-              <a:t>Successfully submit one Pull Request</a:t>
-            </a:r>
-            <a:endParaRPr lang="en-US" sz="1400" dirty="0">
-              <a:effectLst/>
-              <a:latin typeface="Calibri" panose="020F0502020204030204" pitchFamily="34" charset="0"/>
-              <a:ea typeface="Calibri" panose="020F0502020204030204" pitchFamily="34" charset="0"/>
-              <a:cs typeface="Times New Roman" panose="02020603050405020304" pitchFamily="18" charset="0"/>
-            </a:endParaRPr>
+          <p:cNvSpPr>
+            <a:spLocks noGrp="1"/>
+          </p:cNvSpPr>
+          <p:nvPr>
+            <p:ph type="body" idx="1"/>
+          </p:nvPr>
+        </p:nvSpPr>
+        <p:spPr/>
+        <p:txBody>
+          <a:bodyPr/>
+          <a:lstStyle/>
+          <a:p>
+            <a:r>
+              <a:rPr lang="en-US" i="1" dirty="0"/>
+              <a:t>lunch </a:t>
+            </a:r>
+            <a:r>
+              <a:rPr lang="en-US" i="1"/>
+              <a:t>is next!</a:t>
+            </a:r>
+            <a:endParaRPr lang="en-US" i="1" dirty="0"/>
           </a:p>
         </p:txBody>
       </p:sp>
     </p:spTree>
     <p:extLst>
       <p:ext uri="{BB962C8B-B14F-4D97-AF65-F5344CB8AC3E}">
-        <p14:creationId xmlns:p14="http://schemas.microsoft.com/office/powerpoint/2010/main" val="4287364380"/>
+        <p14:creationId xmlns:p14="http://schemas.microsoft.com/office/powerpoint/2010/main" val="271307970"/>
       </p:ext>
     </p:extLst>
   </p:cSld>

</xml_diff>

<commit_message>
Update gitbook 2026-06-16 20:49:18
</commit_message>
<xml_diff>
--- a/MeetTeam.pptx
+++ b/MeetTeam.pptx
@@ -216,7 +216,7 @@
           <a:p>
             <a:fld id="{7CF2004C-AD6B-4A9A-A490-3730F26EBC0C}" type="datetimeFigureOut">
               <a:rPr lang="en-US" smtClean="0"/>
-              <a:t>6/1/2026</a:t>
+              <a:t>6/16/2026</a:t>
             </a:fld>
             <a:endParaRPr lang="en-US"/>
           </a:p>
@@ -614,7 +614,7 @@
           <a:p>
             <a:fld id="{2E6CAD52-DA28-4E78-92DA-C35A0DBEE03A}" type="datetimeFigureOut">
               <a:rPr lang="en-US" smtClean="0"/>
-              <a:t>6/1/2026</a:t>
+              <a:t>6/16/2026</a:t>
             </a:fld>
             <a:endParaRPr lang="en-US"/>
           </a:p>
@@ -784,7 +784,7 @@
           <a:p>
             <a:fld id="{2E6CAD52-DA28-4E78-92DA-C35A0DBEE03A}" type="datetimeFigureOut">
               <a:rPr lang="en-US" smtClean="0"/>
-              <a:t>6/1/2026</a:t>
+              <a:t>6/16/2026</a:t>
             </a:fld>
             <a:endParaRPr lang="en-US"/>
           </a:p>
@@ -964,7 +964,7 @@
           <a:p>
             <a:fld id="{2E6CAD52-DA28-4E78-92DA-C35A0DBEE03A}" type="datetimeFigureOut">
               <a:rPr lang="en-US" smtClean="0"/>
-              <a:t>6/1/2026</a:t>
+              <a:t>6/16/2026</a:t>
             </a:fld>
             <a:endParaRPr lang="en-US"/>
           </a:p>
@@ -1134,7 +1134,7 @@
           <a:p>
             <a:fld id="{2E6CAD52-DA28-4E78-92DA-C35A0DBEE03A}" type="datetimeFigureOut">
               <a:rPr lang="en-US" smtClean="0"/>
-              <a:t>6/1/2026</a:t>
+              <a:t>6/16/2026</a:t>
             </a:fld>
             <a:endParaRPr lang="en-US"/>
           </a:p>
@@ -1380,7 +1380,7 @@
           <a:p>
             <a:fld id="{2E6CAD52-DA28-4E78-92DA-C35A0DBEE03A}" type="datetimeFigureOut">
               <a:rPr lang="en-US" smtClean="0"/>
-              <a:t>6/1/2026</a:t>
+              <a:t>6/16/2026</a:t>
             </a:fld>
             <a:endParaRPr lang="en-US"/>
           </a:p>
@@ -1612,7 +1612,7 @@
           <a:p>
             <a:fld id="{2E6CAD52-DA28-4E78-92DA-C35A0DBEE03A}" type="datetimeFigureOut">
               <a:rPr lang="en-US" smtClean="0"/>
-              <a:t>6/1/2026</a:t>
+              <a:t>6/16/2026</a:t>
             </a:fld>
             <a:endParaRPr lang="en-US"/>
           </a:p>
@@ -1979,7 +1979,7 @@
           <a:p>
             <a:fld id="{2E6CAD52-DA28-4E78-92DA-C35A0DBEE03A}" type="datetimeFigureOut">
               <a:rPr lang="en-US" smtClean="0"/>
-              <a:t>6/1/2026</a:t>
+              <a:t>6/16/2026</a:t>
             </a:fld>
             <a:endParaRPr lang="en-US"/>
           </a:p>
@@ -2097,7 +2097,7 @@
           <a:p>
             <a:fld id="{2E6CAD52-DA28-4E78-92DA-C35A0DBEE03A}" type="datetimeFigureOut">
               <a:rPr lang="en-US" smtClean="0"/>
-              <a:t>6/1/2026</a:t>
+              <a:t>6/16/2026</a:t>
             </a:fld>
             <a:endParaRPr lang="en-US"/>
           </a:p>
@@ -2192,7 +2192,7 @@
           <a:p>
             <a:fld id="{2E6CAD52-DA28-4E78-92DA-C35A0DBEE03A}" type="datetimeFigureOut">
               <a:rPr lang="en-US" smtClean="0"/>
-              <a:t>6/1/2026</a:t>
+              <a:t>6/16/2026</a:t>
             </a:fld>
             <a:endParaRPr lang="en-US"/>
           </a:p>
@@ -2469,7 +2469,7 @@
           <a:p>
             <a:fld id="{2E6CAD52-DA28-4E78-92DA-C35A0DBEE03A}" type="datetimeFigureOut">
               <a:rPr lang="en-US" smtClean="0"/>
-              <a:t>6/1/2026</a:t>
+              <a:t>6/16/2026</a:t>
             </a:fld>
             <a:endParaRPr lang="en-US"/>
           </a:p>
@@ -2726,7 +2726,7 @@
           <a:p>
             <a:fld id="{2E6CAD52-DA28-4E78-92DA-C35A0DBEE03A}" type="datetimeFigureOut">
               <a:rPr lang="en-US" smtClean="0"/>
-              <a:t>6/1/2026</a:t>
+              <a:t>6/16/2026</a:t>
             </a:fld>
             <a:endParaRPr lang="en-US"/>
           </a:p>
@@ -2939,7 +2939,7 @@
           <a:p>
             <a:fld id="{2E6CAD52-DA28-4E78-92DA-C35A0DBEE03A}" type="datetimeFigureOut">
               <a:rPr lang="en-US" smtClean="0"/>
-              <a:t>6/1/2026</a:t>
+              <a:t>6/16/2026</a:t>
             </a:fld>
             <a:endParaRPr lang="en-US"/>
           </a:p>
@@ -4357,7 +4357,7 @@
             <p:ph idx="1"/>
             <p:extLst>
               <p:ext uri="{D42A27DB-BD31-4B8C-83A1-F6EECF244321}">
-                <p14:modId xmlns:p14="http://schemas.microsoft.com/office/powerpoint/2010/main" val="516400332"/>
+                <p14:modId xmlns:p14="http://schemas.microsoft.com/office/powerpoint/2010/main" val="2087895091"/>
               </p:ext>
             </p:extLst>
           </p:nvPr>
@@ -4502,7 +4502,7 @@
                       <a:pPr algn="ctr"/>
                       <a:r>
                         <a:rPr lang="en-US" sz="2800" dirty="0"/>
-                        <a:t>1:00pm-2:00pm</a:t>
+                        <a:t>1:30pm-2:30pm</a:t>
                       </a:r>
                     </a:p>
                   </a:txBody>
@@ -4536,9 +4536,10 @@
                     <a:p>
                       <a:pPr algn="ctr"/>
                       <a:r>
-                        <a:rPr lang="en-US" sz="2800" dirty="0"/>
-                        <a:t>2:00pm-4:00pm</a:t>
+                        <a:rPr lang="en-US" sz="2800"/>
+                        <a:t>2:30pm-4:00pm</a:t>
                       </a:r>
+                      <a:endParaRPr lang="en-US" sz="2800" dirty="0"/>
                     </a:p>
                   </a:txBody>
                   <a:tcPr anchor="ctr"/>

</xml_diff>